<commit_message>
Rebuild audited figures and tables
Co-Authored-By: Tatsuki Onishi <bougtoir@gmail.com>
</commit_message>
<xml_diff>
--- a/manuscript/editable_figures_CRST.pptx
+++ b/manuscript/editable_figures_CRST.pptx
@@ -3356,8 +3356,8 @@
         </p:blipFill>
         <p:spPr>
           <a:xfrm>
-            <a:off x="2789950" y="777240"/>
-            <a:ext cx="6611794" cy="5120640"/>
+            <a:off x="609447" y="978556"/>
+            <a:ext cx="10972800" cy="4718007"/>
           </a:xfrm>
           <a:prstGeom prst="rect">
             <a:avLst/>
@@ -3391,7 +3391,7 @@
               <a:rPr sz="1100">
                 <a:latin typeface="Arial"/>
               </a:rPr>
-              <a:t>Figure 3. Primary modeled retained-mass and release-mass Pareto comparison.</a:t>
+              <a:t>Figure 3. Unique objective pairs for the exhaustive uniform and heuristic joint sets, shown over the full range and the intermediate trade-off region.</a:t>
             </a:r>
           </a:p>
         </p:txBody>
@@ -3462,8 +3462,8 @@
         </p:blipFill>
         <p:spPr>
           <a:xfrm>
-            <a:off x="2255367" y="777240"/>
-            <a:ext cx="7680960" cy="5120640"/>
+            <a:off x="3352470" y="777240"/>
+            <a:ext cx="5486753" cy="5120640"/>
           </a:xfrm>
           <a:prstGeom prst="rect">
             <a:avLst/>
@@ -3497,7 +3497,7 @@
               <a:rPr sz="1100">
                 <a:latin typeface="Arial"/>
               </a:rPr>
-              <a:t>Figure 4. Selected graded joint profile and generic mapped surface classes.</a:t>
+              <a:t>Figure 4. Continuous joint-knee slope and friction profiles compared with the post hoc segmented, generic-class mapping.</a:t>
             </a:r>
           </a:p>
         </p:txBody>
@@ -3603,7 +3603,7 @@
               <a:rPr sz="1100">
                 <a:latin typeface="Arial"/>
               </a:rPr>
-              <a:t>Figure 5. Geometry-only, surface-only, and joint heterogeneous Pareto fronts.</a:t>
+              <a:t>Figure 5. Unique objective pairs for the uniform, geometry-only, surface-only, and joint sets.</a:t>
             </a:r>
           </a:p>
         </p:txBody>
@@ -3674,8 +3674,8 @@
         </p:blipFill>
         <p:spPr>
           <a:xfrm>
-            <a:off x="748830" y="777240"/>
-            <a:ext cx="10694033" cy="5120640"/>
+            <a:off x="2768543" y="777240"/>
+            <a:ext cx="6654608" cy="5120640"/>
           </a:xfrm>
           <a:prstGeom prst="rect">
             <a:avLst/>
@@ -3709,7 +3709,7 @@
               <a:rPr sz="1100">
                 <a:latin typeface="Arial"/>
               </a:rPr>
-              <a:t>Figure 6. Numerical convergence relative to the finest tested resolution.</a:t>
+              <a:t>Figure 6. Four-metric numerical convergence relative to the 48-cell, 0.5-h reference; the dashed line is the frozen relative-error tolerance.</a:t>
             </a:r>
           </a:p>
         </p:txBody>
@@ -3780,8 +3780,8 @@
         </p:blipFill>
         <p:spPr>
           <a:xfrm>
-            <a:off x="2418740" y="777240"/>
-            <a:ext cx="7354214" cy="5120640"/>
+            <a:off x="2886523" y="777240"/>
+            <a:ext cx="6418647" cy="5120640"/>
           </a:xfrm>
           <a:prstGeom prst="rect">
             <a:avLst/>
@@ -3815,7 +3815,7 @@
               <a:rPr sz="1100">
                 <a:latin typeface="Arial"/>
               </a:rPr>
-              <a:t>Figure 7. Prespecified one-at-a-time sensitivity of primary outcomes.</a:t>
+              <a:t>Figure 7. Prespecified one-at-a-time sensitivity. Labels state each low/high factor or encoded alternative; bars are relative changes from baseline.</a:t>
             </a:r>
           </a:p>
         </p:txBody>
@@ -3886,8 +3886,8 @@
         </p:blipFill>
         <p:spPr>
           <a:xfrm>
-            <a:off x="2605697" y="777240"/>
-            <a:ext cx="6980300" cy="5120640"/>
+            <a:off x="2190890" y="777240"/>
+            <a:ext cx="7809914" cy="5120640"/>
           </a:xfrm>
           <a:prstGeom prst="rect">
             <a:avLst/>
@@ -3921,7 +3921,7 @@
               <a:rPr sz="1100">
                 <a:latin typeface="Arial"/>
               </a:rPr>
-              <a:t>Figure 8. Monte Carlo perturbation distributions for frontier candidates.</a:t>
+              <a:t>Figure 8. Candidate-specific Q95 retained-mass and release-mass outcomes under 250 paired perturbation draws. Symmetric-log axes include zero outcomes.</a:t>
             </a:r>
           </a:p>
         </p:txBody>
@@ -3992,8 +3992,8 @@
         </p:blipFill>
         <p:spPr>
           <a:xfrm>
-            <a:off x="922122" y="777240"/>
-            <a:ext cx="10347449" cy="5120640"/>
+            <a:off x="1109029" y="777240"/>
+            <a:ext cx="9973637" cy="5120640"/>
           </a:xfrm>
           <a:prstGeom prst="rect">
             <a:avLst/>
@@ -4027,7 +4027,7 @@
               <a:rPr sz="1100">
                 <a:latin typeface="Arial"/>
               </a:rPr>
-              <a:t>Figure 9. Labor-scarcity selections and frozen strategy classifications.</a:t>
+              <a:t>Figure 9. Frozen labor-scarcity selections in the base decision scenario and phase-diagram objective pairs; bubble area reflects selection frequency.</a:t>
             </a:r>
           </a:p>
         </p:txBody>

</xml_diff>

<commit_message>
Complete deterministic 0.5-hour production revision
Co-Authored-By: Tatsuki Onishi <bougtoir@gmail.com>
</commit_message>
<xml_diff>
--- a/manuscript/editable_figures_CRST.pptx
+++ b/manuscript/editable_figures_CRST.pptx
@@ -3462,8 +3462,8 @@
         </p:blipFill>
         <p:spPr>
           <a:xfrm>
-            <a:off x="3352470" y="777240"/>
-            <a:ext cx="5486753" cy="5120640"/>
+            <a:off x="3351234" y="777240"/>
+            <a:ext cx="5489227" cy="5120640"/>
           </a:xfrm>
           <a:prstGeom prst="rect">
             <a:avLst/>
@@ -3780,8 +3780,8 @@
         </p:blipFill>
         <p:spPr>
           <a:xfrm>
-            <a:off x="2886523" y="777240"/>
-            <a:ext cx="6418647" cy="5120640"/>
+            <a:off x="2885442" y="777240"/>
+            <a:ext cx="6420810" cy="5120640"/>
           </a:xfrm>
           <a:prstGeom prst="rect">
             <a:avLst/>
@@ -3992,8 +3992,8 @@
         </p:blipFill>
         <p:spPr>
           <a:xfrm>
-            <a:off x="1109029" y="777240"/>
-            <a:ext cx="9973637" cy="5120640"/>
+            <a:off x="969303" y="777240"/>
+            <a:ext cx="10253087" cy="5120640"/>
           </a:xfrm>
           <a:prstGeom prst="rect">
             <a:avLst/>

</xml_diff>

<commit_message>
Finalize CRST submission package
Co-Authored-By: Tatsuki Onishi <bougtoir@gmail.com>
</commit_message>
<xml_diff>
--- a/manuscript/editable_figures_CRST.pptx
+++ b/manuscript/editable_figures_CRST.pptx
@@ -3497,7 +3497,7 @@
               <a:rPr sz="1100">
                 <a:latin typeface="Arial"/>
               </a:rPr>
-              <a:t>Figure 4. Continuous joint-knee slope and friction profiles compared with the post hoc segmented, generic-class mapping.</a:t>
+              <a:t>Figure 4. Continuous joint-knee slope and friction profiles compared with the post hoc rule-compliant segmented, generic-class mapping; the mapped profile is not a constrained optimum.</a:t>
             </a:r>
           </a:p>
         </p:txBody>
@@ -3709,7 +3709,7 @@
               <a:rPr sz="1100">
                 <a:latin typeface="Arial"/>
               </a:rPr>
-              <a:t>Figure 6. Four-metric numerical convergence relative to the 48-cell, 0.5-h reference; the dashed line is the frozen relative-error tolerance.</a:t>
+              <a:t>Figure 6. Four-metric numerical-resolution comparison relative to the 48-cell, 0.5-h reference; the dashed line is the frozen relative-error tolerance.</a:t>
             </a:r>
           </a:p>
         </p:txBody>

</xml_diff>